<commit_message>
RX-03 done: PVT corner sweep of the write chain
tt/ss/ff/sf/fs: monotonic at all corners; LSB within +/-4% except sf;
sf skew corner bows the transfer to -39.4 mV (1.68 V_T, INL 9.3 LSB,
18 mV code-dependent offset) — first corner-dependent design constraint,
absorbable by one-time per-code calibration. Settle 5.5-14.2 ns, gated
k=3 energy 13.7-16.3 pJ, projection correction spans x14-26 (time) /
x17-21 (energy) across corners. New fig 3.9(d) panel via the PPT
pipeline (slide height raised for 3-row figure); 表3.9 note, 3.5.1
prose, 3.5.4 corner band, 3.5.5 caveat updated.

Co-Authored-By: Claude Fable 5 <noreply@anthropic.com>
</commit_message>
<xml_diff>
--- a/article/ppt/Chapter03_local.pptx
+++ b/article/ppt/Chapter03_local.pptx
@@ -9,7 +9,7 @@
     <p:sldId id="257" r:id="rId8"/>
     <p:sldId id="258" r:id="rId9"/>
   </p:sldIdLst>
-  <p:sldSz cx="9144000" cy="9144000" type="screen4x3"/>
+  <p:sldSz cx="9144000" cy="11887200" type="screen4x3"/>
   <p:notesSz cx="6858000" cy="9144000"/>
   <p:defaultTextStyle>
     <a:defPPr>
@@ -3260,6 +3260,64 @@
                 <a:latin typeface="Arial"/>
               </a:rPr>
               <a:t>(c)</a:t>
+            </a:r>
+          </a:p>
+        </p:txBody>
+      </p:sp>
+      <p:pic>
+        <p:nvPicPr>
+          <p:cNvPr id="8" name="Picture 7" descr="chain_corners.png"/>
+          <p:cNvPicPr>
+            <a:picLocks noChangeAspect="1"/>
+          </p:cNvPicPr>
+          <p:nvPr/>
+        </p:nvPicPr>
+        <p:blipFill>
+          <a:blip r:embed="rId5"/>
+          <a:stretch>
+            <a:fillRect/>
+          </a:stretch>
+        </p:blipFill>
+        <p:spPr>
+          <a:xfrm>
+            <a:off x="228600" y="8530492"/>
+            <a:ext cx="8686800" cy="2553272"/>
+          </a:xfrm>
+          <a:prstGeom prst="rect">
+            <a:avLst/>
+          </a:prstGeom>
+        </p:spPr>
+      </p:pic>
+      <p:sp>
+        <p:nvSpPr>
+          <p:cNvPr id="9" name="TextBox 8"/>
+          <p:cNvSpPr txBox="1"/>
+          <p:nvPr/>
+        </p:nvSpPr>
+        <p:spPr>
+          <a:xfrm>
+            <a:off x="265176" y="8548780"/>
+            <a:ext cx="457200" cy="274320"/>
+          </a:xfrm>
+          <a:prstGeom prst="rect">
+            <a:avLst/>
+          </a:prstGeom>
+          <a:noFill/>
+        </p:spPr>
+        <p:txBody>
+          <a:bodyPr wrap="none" lIns="0" rIns="0" tIns="0" bIns="0">
+            <a:spAutoFit/>
+          </a:bodyPr>
+          <a:lstStyle/>
+          <a:p>
+            <a:r>
+              <a:rPr b="1" sz="1500">
+                <a:solidFill>
+                  <a:srgbClr val="202020"/>
+                </a:solidFill>
+                <a:latin typeface="Arial"/>
+              </a:rPr>
+              <a:t>(d)</a:t>
             </a:r>
           </a:p>
         </p:txBody>

</xml_diff>

<commit_message>
Add RX-11 density panel as 图3.3(d); rebuild 图3.3 through the figure pipeline
Per the user's choice, the controlled-degree-ladder result joins the
Gibbs-vs-SA comparison it extends rather than becoming a standalone
figure (which would have renumbered 图3.4-3.11, ~40 in-text refs). 图3.3
(image file Chapter03_local_07.png) is now regenerated from committed
data through figs_make + build_ppt_figs like the circuit figures:
- (a)(b)(c) faithfully reproduce the existing wall-clock TTS bars from
  results_rerun/results_compare_{factor,maxcut,tsp}/summary.csv, the same
  batch 表3.3 quotes (G22 317.81/1180.39 s); warm purple + orange to sit
  with the neighbouring user-composed figures.
- (d) is the RX-11 ladder (degree 6-96, ratio vs mean degree, G1/G22
  overlaid at their measured degrees).
Caption gains (d); the §3.3.1 ladder paragraph now cites 图3.3(d). The
raw density panel is no longer orphaned in figs_raw.

Co-Authored-By: Claude Fable 5 <noreply@anthropic.com>
</commit_message>
<xml_diff>
--- a/article/ppt/Chapter03_local.pptx
+++ b/article/ppt/Chapter03_local.pptx
@@ -8,6 +8,7 @@
     <p:sldId id="256" r:id="rId7"/>
     <p:sldId id="257" r:id="rId8"/>
     <p:sldId id="258" r:id="rId9"/>
+    <p:sldId id="259" r:id="rId10"/>
   </p:sldIdLst>
   <p:sldSz cx="9144000" cy="11887200" type="screen4x3"/>
   <p:notesSz cx="6858000" cy="9144000"/>
@@ -3092,6 +3093,256 @@
       <p:grpSpPr/>
       <p:pic>
         <p:nvPicPr>
+          <p:cNvPr id="2" name="Picture 1" descr="tts_factor.png"/>
+          <p:cNvPicPr>
+            <a:picLocks noChangeAspect="1"/>
+          </p:cNvPicPr>
+          <p:nvPr/>
+        </p:nvPicPr>
+        <p:blipFill>
+          <a:blip r:embed="rId2"/>
+          <a:stretch>
+            <a:fillRect/>
+          </a:stretch>
+        </p:blipFill>
+        <p:spPr>
+          <a:xfrm>
+            <a:off x="228600" y="384048"/>
+            <a:ext cx="8686800" cy="2682524"/>
+          </a:xfrm>
+          <a:prstGeom prst="rect">
+            <a:avLst/>
+          </a:prstGeom>
+        </p:spPr>
+      </p:pic>
+      <p:sp>
+        <p:nvSpPr>
+          <p:cNvPr id="3" name="TextBox 2"/>
+          <p:cNvSpPr txBox="1"/>
+          <p:nvPr/>
+        </p:nvSpPr>
+        <p:spPr>
+          <a:xfrm>
+            <a:off x="265176" y="402336"/>
+            <a:ext cx="457200" cy="274320"/>
+          </a:xfrm>
+          <a:prstGeom prst="rect">
+            <a:avLst/>
+          </a:prstGeom>
+          <a:noFill/>
+        </p:spPr>
+        <p:txBody>
+          <a:bodyPr wrap="none" lIns="0" rIns="0" tIns="0" bIns="0">
+            <a:spAutoFit/>
+          </a:bodyPr>
+          <a:lstStyle/>
+          <a:p>
+            <a:r>
+              <a:rPr b="1" sz="1500">
+                <a:solidFill>
+                  <a:srgbClr val="202020"/>
+                </a:solidFill>
+                <a:latin typeface="Arial"/>
+              </a:rPr>
+              <a:t>(a)</a:t>
+            </a:r>
+          </a:p>
+        </p:txBody>
+      </p:sp>
+      <p:pic>
+        <p:nvPicPr>
+          <p:cNvPr id="4" name="Picture 3" descr="tts_maxcut.png"/>
+          <p:cNvPicPr>
+            <a:picLocks noChangeAspect="1"/>
+          </p:cNvPicPr>
+          <p:nvPr/>
+        </p:nvPicPr>
+        <p:blipFill>
+          <a:blip r:embed="rId3"/>
+          <a:stretch>
+            <a:fillRect/>
+          </a:stretch>
+        </p:blipFill>
+        <p:spPr>
+          <a:xfrm>
+            <a:off x="228600" y="3212876"/>
+            <a:ext cx="4270248" cy="2922200"/>
+          </a:xfrm>
+          <a:prstGeom prst="rect">
+            <a:avLst/>
+          </a:prstGeom>
+        </p:spPr>
+      </p:pic>
+      <p:sp>
+        <p:nvSpPr>
+          <p:cNvPr id="5" name="TextBox 4"/>
+          <p:cNvSpPr txBox="1"/>
+          <p:nvPr/>
+        </p:nvSpPr>
+        <p:spPr>
+          <a:xfrm>
+            <a:off x="265176" y="3231164"/>
+            <a:ext cx="457200" cy="274320"/>
+          </a:xfrm>
+          <a:prstGeom prst="rect">
+            <a:avLst/>
+          </a:prstGeom>
+          <a:noFill/>
+        </p:spPr>
+        <p:txBody>
+          <a:bodyPr wrap="none" lIns="0" rIns="0" tIns="0" bIns="0">
+            <a:spAutoFit/>
+          </a:bodyPr>
+          <a:lstStyle/>
+          <a:p>
+            <a:r>
+              <a:rPr b="1" sz="1500">
+                <a:solidFill>
+                  <a:srgbClr val="202020"/>
+                </a:solidFill>
+                <a:latin typeface="Arial"/>
+              </a:rPr>
+              <a:t>(b)</a:t>
+            </a:r>
+          </a:p>
+        </p:txBody>
+      </p:sp>
+      <p:pic>
+        <p:nvPicPr>
+          <p:cNvPr id="6" name="Picture 5" descr="tts_tsp.png"/>
+          <p:cNvPicPr>
+            <a:picLocks noChangeAspect="1"/>
+          </p:cNvPicPr>
+          <p:nvPr/>
+        </p:nvPicPr>
+        <p:blipFill>
+          <a:blip r:embed="rId4"/>
+          <a:stretch>
+            <a:fillRect/>
+          </a:stretch>
+        </p:blipFill>
+        <p:spPr>
+          <a:xfrm>
+            <a:off x="4645152" y="3212876"/>
+            <a:ext cx="4270248" cy="2914387"/>
+          </a:xfrm>
+          <a:prstGeom prst="rect">
+            <a:avLst/>
+          </a:prstGeom>
+        </p:spPr>
+      </p:pic>
+      <p:sp>
+        <p:nvSpPr>
+          <p:cNvPr id="7" name="TextBox 6"/>
+          <p:cNvSpPr txBox="1"/>
+          <p:nvPr/>
+        </p:nvSpPr>
+        <p:spPr>
+          <a:xfrm>
+            <a:off x="4681728" y="3231164"/>
+            <a:ext cx="457200" cy="274320"/>
+          </a:xfrm>
+          <a:prstGeom prst="rect">
+            <a:avLst/>
+          </a:prstGeom>
+          <a:noFill/>
+        </p:spPr>
+        <p:txBody>
+          <a:bodyPr wrap="none" lIns="0" rIns="0" tIns="0" bIns="0">
+            <a:spAutoFit/>
+          </a:bodyPr>
+          <a:lstStyle/>
+          <a:p>
+            <a:r>
+              <a:rPr b="1" sz="1500">
+                <a:solidFill>
+                  <a:srgbClr val="202020"/>
+                </a:solidFill>
+                <a:latin typeface="Arial"/>
+              </a:rPr>
+              <a:t>(c)</a:t>
+            </a:r>
+          </a:p>
+        </p:txBody>
+      </p:sp>
+      <p:pic>
+        <p:nvPicPr>
+          <p:cNvPr id="8" name="Picture 7" descr="density_sweep.png"/>
+          <p:cNvPicPr>
+            <a:picLocks noChangeAspect="1"/>
+          </p:cNvPicPr>
+          <p:nvPr/>
+        </p:nvPicPr>
+        <p:blipFill>
+          <a:blip r:embed="rId5"/>
+          <a:stretch>
+            <a:fillRect/>
+          </a:stretch>
+        </p:blipFill>
+        <p:spPr>
+          <a:xfrm>
+            <a:off x="228600" y="6281380"/>
+            <a:ext cx="8686800" cy="5773214"/>
+          </a:xfrm>
+          <a:prstGeom prst="rect">
+            <a:avLst/>
+          </a:prstGeom>
+        </p:spPr>
+      </p:pic>
+      <p:sp>
+        <p:nvSpPr>
+          <p:cNvPr id="9" name="TextBox 8"/>
+          <p:cNvSpPr txBox="1"/>
+          <p:nvPr/>
+        </p:nvSpPr>
+        <p:spPr>
+          <a:xfrm>
+            <a:off x="265176" y="6299668"/>
+            <a:ext cx="457200" cy="274320"/>
+          </a:xfrm>
+          <a:prstGeom prst="rect">
+            <a:avLst/>
+          </a:prstGeom>
+          <a:noFill/>
+        </p:spPr>
+        <p:txBody>
+          <a:bodyPr wrap="none" lIns="0" rIns="0" tIns="0" bIns="0">
+            <a:spAutoFit/>
+          </a:bodyPr>
+          <a:lstStyle/>
+          <a:p>
+            <a:r>
+              <a:rPr b="1" sz="1500">
+                <a:solidFill>
+                  <a:srgbClr val="202020"/>
+                </a:solidFill>
+                <a:latin typeface="Arial"/>
+              </a:rPr>
+              <a:t>(d)</a:t>
+            </a:r>
+          </a:p>
+        </p:txBody>
+      </p:sp>
+    </p:spTree>
+  </p:cSld>
+  <p:clrMapOvr>
+    <a:masterClrMapping/>
+  </p:clrMapOvr>
+</p:sld>
+</file>
+
+<file path=ppt/slides/slide2.xml><?xml version="1.0" encoding="utf-8"?>
+<p:sld xmlns:a="http://schemas.openxmlformats.org/drawingml/2006/main" xmlns:p="http://schemas.openxmlformats.org/presentationml/2006/main" xmlns:r="http://schemas.openxmlformats.org/officeDocument/2006/relationships">
+  <p:cSld>
+    <p:spTree>
+      <p:nvGrpSpPr>
+        <p:cNvPr id="1" name=""/>
+        <p:cNvGrpSpPr/>
+        <p:nvPr/>
+      </p:nvGrpSpPr>
+      <p:grpSpPr/>
+      <p:pic>
+        <p:nvPicPr>
           <p:cNvPr id="2" name="Picture 1" descr="chain_schematic.png"/>
           <p:cNvPicPr>
             <a:picLocks noChangeAspect="1"/>
@@ -3330,7 +3581,7 @@
 </p:sld>
 </file>
 
-<file path=ppt/slides/slide2.xml><?xml version="1.0" encoding="utf-8"?>
+<file path=ppt/slides/slide3.xml><?xml version="1.0" encoding="utf-8"?>
 <p:sld xmlns:a="http://schemas.openxmlformats.org/drawingml/2006/main" xmlns:p="http://schemas.openxmlformats.org/presentationml/2006/main" xmlns:r="http://schemas.openxmlformats.org/officeDocument/2006/relationships">
   <p:cSld>
     <p:spTree>
@@ -3638,7 +3889,7 @@
 </p:sld>
 </file>
 
-<file path=ppt/slides/slide3.xml><?xml version="1.0" encoding="utf-8"?>
+<file path=ppt/slides/slide4.xml><?xml version="1.0" encoding="utf-8"?>
 <p:sld xmlns:a="http://schemas.openxmlformats.org/drawingml/2006/main" xmlns:p="http://schemas.openxmlformats.org/presentationml/2006/main" xmlns:r="http://schemas.openxmlformats.org/officeDocument/2006/relationships">
   <p:cSld>
     <p:spTree>

</xml_diff>